<commit_message>
Tell the guide about the Google Sheets store
The sharing table listed only a network folder or an in-house server, so
the new option had no explanation anywhere a user would look. It now
distinguishes the two cases plainly: folder or server inside one factory,
Google Sheets between sites too far apart to share either, and notes that
a blocked Google is skipped rather than broken.

All three languages carry the row, and the decks are rebuilt from the
page so they do not drift from it.

Co-Authored-By: Claude Opus 5 <noreply@anthropic.com>
</commit_message>
<xml_diff>
--- a/PIE_가이드_TiengViet.pptx
+++ b/PIE_가이드_TiengViet.pptx
@@ -28247,7 +28247,7 @@
         </p:nvGraphicFramePr>
         <p:xfrm>
           <a:off x="640080" y="1143000"/>
-          <a:ext cx="10881360" cy="1481328"/>
+          <a:ext cx="10881360" cy="1773936"/>
         </p:xfrm>
         <a:graphic>
           <a:graphicData uri="http://schemas.openxmlformats.org/drawingml/2006/table">
@@ -28260,7 +28260,7 @@
                 <a:gridCol w="3627120"/>
                 <a:gridCol w="3627120"/>
               </a:tblGrid>
-              <a:tr h="296265">
+              <a:tr h="295656">
                 <a:tc>
                   <a:txBody>
                     <a:bodyPr/>
@@ -28328,7 +28328,7 @@
                   </a:tcPr>
                 </a:tc>
               </a:tr>
-              <a:tr h="296265">
+              <a:tr h="295656">
                 <a:tc>
                   <a:txBody>
                     <a:bodyPr/>
@@ -28411,7 +28411,7 @@
                   </a:tcPr>
                 </a:tc>
               </a:tr>
-              <a:tr h="296265">
+              <a:tr h="295656">
                 <a:tc>
                   <a:txBody>
                     <a:bodyPr/>
@@ -28494,7 +28494,7 @@
                   </a:tcPr>
                 </a:tc>
               </a:tr>
-              <a:tr h="296265">
+              <a:tr h="295656">
                 <a:tc>
                   <a:txBody>
                     <a:bodyPr/>
@@ -28577,7 +28577,7 @@
                   </a:tcPr>
                 </a:tc>
               </a:tr>
-              <a:tr h="296268">
+              <a:tr h="295656">
                 <a:tc>
                   <a:txBody>
                     <a:bodyPr/>
@@ -28649,7 +28649,7 @@
                           </a:solidFill>
                           <a:latin typeface="Segoe UI"/>
                         </a:rPr>
-                        <a:t>Khi nhiều máy cùng tích lũy chung thời gian chuẩn</a:t>
+                        <a:t>Khi tích lũy chung trong cùng một nhà máy</a:t>
                       </a:r>
                     </a:p>
                   </a:txBody>
@@ -28660,6 +28660,98 @@
                   </a:tcPr>
                 </a:tc>
               </a:tr>
+              <a:tr h="295656">
+                <a:tc>
+                  <a:txBody>
+                    <a:bodyPr/>
+                    <a:lstStyle/>
+                    <a:p>
+                      <a:pPr>
+                        <a:lnSpc>
+                          <a:spcPct val="95000"/>
+                        </a:lnSpc>
+                      </a:pPr>
+                      <a:r>
+                        <a:rPr sz="1100" b="0">
+                          <a:solidFill>
+                            <a:srgbClr val="111827"/>
+                          </a:solidFill>
+                          <a:latin typeface="Segoe UI"/>
+                        </a:rPr>
+                        <a:t>Cài đặt &gt; Kho lưu trữ chung &gt; 📊 Google Sheets</a:t>
+                      </a:r>
+                    </a:p>
+                  </a:txBody>
+                  <a:tcPr marL="54864" marR="54864" marT="18288" marB="18288">
+                    <a:solidFill>
+                      <a:srgbClr val="F1F5F9"/>
+                    </a:solidFill>
+                  </a:tcPr>
+                </a:tc>
+                <a:tc>
+                  <a:txBody>
+                    <a:bodyPr/>
+                    <a:lstStyle/>
+                    <a:p>
+                      <a:pPr>
+                        <a:lnSpc>
+                          <a:spcPct val="95000"/>
+                        </a:lnSpc>
+                      </a:pPr>
+                      <a:r>
+                        <a:rPr sz="1100" b="0">
+                          <a:solidFill>
+                            <a:srgbClr val="111827"/>
+                          </a:solidFill>
+                          <a:latin typeface="Segoe UI"/>
+                        </a:rPr>
+                        <a:t>Google Trang tính</a:t>
+                      </a:r>
+                    </a:p>
+                  </a:txBody>
+                  <a:tcPr marL="54864" marR="54864" marT="18288" marB="18288">
+                    <a:solidFill>
+                      <a:srgbClr val="F1F5F9"/>
+                    </a:solidFill>
+                  </a:tcPr>
+                </a:tc>
+                <a:tc>
+                  <a:txBody>
+                    <a:bodyPr/>
+                    <a:lstStyle/>
+                    <a:p>
+                      <a:pPr>
+                        <a:lnSpc>
+                          <a:spcPct val="95000"/>
+                        </a:lnSpc>
+                      </a:pPr>
+                      <a:r>
+                        <a:rPr sz="1100" b="1">
+                          <a:solidFill>
+                            <a:srgbClr val="111827"/>
+                          </a:solidFill>
+                          <a:latin typeface="Segoe UI"/>
+                        </a:rPr>
+                        <a:t>Khi chia sẻ giữa các khu vực xa nhau</a:t>
+                      </a:r>
+                      <a:r>
+                        <a:rPr sz="1100" b="0">
+                          <a:solidFill>
+                            <a:srgbClr val="111827"/>
+                          </a:solidFill>
+                          <a:latin typeface="Segoe UI"/>
+                        </a:rPr>
+                        <a:t> (cần Internet)</a:t>
+                      </a:r>
+                    </a:p>
+                  </a:txBody>
+                  <a:tcPr marL="54864" marR="54864" marT="18288" marB="18288">
+                    <a:solidFill>
+                      <a:srgbClr val="F1F5F9"/>
+                    </a:solidFill>
+                  </a:tcPr>
+                </a:tc>
+              </a:tr>
             </a:tbl>
           </a:graphicData>
         </a:graphic>
@@ -28672,7 +28764,7 @@
         </p:nvSpPr>
         <p:spPr>
           <a:xfrm>
-            <a:off x="640080" y="2852928"/>
+            <a:off x="640080" y="3145536"/>
             <a:ext cx="10881360" cy="566928"/>
           </a:xfrm>
           <a:prstGeom prst="roundRect">
@@ -28720,7 +28812,7 @@
         </p:nvSpPr>
         <p:spPr>
           <a:xfrm>
-            <a:off x="822960" y="2852928"/>
+            <a:off x="822960" y="3145536"/>
             <a:ext cx="10515600" cy="566928"/>
           </a:xfrm>
           <a:prstGeom prst="rect">

</xml_diff>

<commit_message>
Rename the launcher now that there is only one edition
Calling it PIE(중국).bat implied a China-only build and reopened the very
confusion that merging the two editions removed. It is now PIE 실행.bat,
with the window title and its own messages cleaned up to match, and the
35 references across the installer, packager, guide and docs updated. The
worklog keeps the old name where it records history.

The word 실행 is there so the file stays distinguishable from PIE.html on
machines that hide extensions.

Co-Authored-By: Claude Opus 5 <noreply@anthropic.com>
</commit_message>
<xml_diff>
--- a/PIE_가이드_TiengViet.pptx
+++ b/PIE_가이드_TiengViet.pptx
@@ -29460,7 +29460,7 @@
                           </a:solidFill>
                           <a:latin typeface="Segoe UI"/>
                         </a:rPr>
-                        <a:t>PIE(중국).bat</a:t>
+                        <a:t>PIE 실행.bat</a:t>
                       </a:r>
                       <a:r>
                         <a:rPr sz="1100" b="0">
@@ -32558,7 +32558,7 @@
                 </a:solidFill>
                 <a:latin typeface="Segoe UI"/>
               </a:rPr>
-              <a:t>PIE(중국).bat</a:t>
+              <a:t>PIE 실행.bat</a:t>
             </a:r>
             <a:r>
               <a:rPr sz="1300" b="0">
@@ -32838,7 +32838,7 @@
                 </a:solidFill>
                 <a:latin typeface="Segoe UI"/>
               </a:rPr>
-              <a:t>Nhấp đúp PIE(중국).bat</a:t>
+              <a:t>Nhấp đúp PIE 실행.bat</a:t>
             </a:r>
           </a:p>
         </p:txBody>
@@ -33667,7 +33667,7 @@
                 </a:solidFill>
                 <a:latin typeface="Segoe UI"/>
               </a:rPr>
-              <a:t>PIE(중국).bat</a:t>
+              <a:t>PIE 실행.bat</a:t>
             </a:r>
             <a:r>
               <a:rPr sz="1300" b="0">

</xml_diff>